<commit_message>
Fix PowerPoint repair error in variable deck
pptxgenjs bullet lists (a:buChar) triggered a PowerPoint repair/unreadable
error while the analysis deck (no bullets) opened fine. Replace the
bullet:{code} option with literal bullet-char prefixes so the deck's XML
matches the working deck's construct set. Visually identical.
</commit_message>
<xml_diff>
--- a/presentations/ClimSim_변수정리.pptx
+++ b/presentations/ClimSim_변수정리.pptx
@@ -8777,12 +8777,11 @@
           <a:bodyPr wrap="square" rtlCol="0" anchor="t"/>
           <a:lstStyle/>
           <a:p>
-            <a:pPr marL="342900" indent="-342900">
+            <a:pPr indent="0" marL="0">
               <a:spcAft>
                 <a:spcPts val="900"/>
               </a:spcAft>
-              <a:buSzPct val="100000"/>
-              <a:buChar char="•"/>
+              <a:buNone/>
             </a:pPr>
             <a:r>
               <a:rPr lang="en-US" sz="1550" dirty="0">
@@ -8790,17 +8789,16 @@
                   <a:srgbClr val="13233A"/>
                 </a:solidFill>
               </a:rPr>
-              <a:t>각 연직 층의 공기 온도</a:t>
+              <a:t>•   각 연직 층의 공기 온도</a:t>
             </a:r>
             <a:endParaRPr lang="en-US" sz="1550" dirty="0"/>
           </a:p>
           <a:p>
-            <a:pPr marL="342900" indent="-342900">
+            <a:pPr indent="0" marL="0">
               <a:spcAft>
                 <a:spcPts val="900"/>
               </a:spcAft>
-              <a:buSzPct val="100000"/>
-              <a:buChar char="•"/>
+              <a:buNone/>
             </a:pPr>
             <a:r>
               <a:rPr lang="en-US" sz="1550" dirty="0">
@@ -8808,17 +8806,16 @@
                   <a:srgbClr val="13233A"/>
                 </a:solidFill>
               </a:rPr>
-              <a:t>하층(59)은 따뜻, 상층(0)은 차갑다</a:t>
+              <a:t>•   하층(59)은 따뜻, 상층(0)은 차갑다</a:t>
             </a:r>
             <a:endParaRPr lang="en-US" sz="1550" dirty="0"/>
           </a:p>
           <a:p>
-            <a:pPr marL="342900" indent="-342900">
+            <a:pPr indent="0" marL="0">
               <a:spcAft>
                 <a:spcPts val="900"/>
               </a:spcAft>
-              <a:buSzPct val="100000"/>
-              <a:buChar char="•"/>
+              <a:buNone/>
             </a:pPr>
             <a:r>
               <a:rPr lang="en-US" sz="1550" dirty="0">
@@ -8826,17 +8823,16 @@
                   <a:srgbClr val="13233A"/>
                 </a:solidFill>
               </a:rPr>
-              <a:t>짝이 되는 출력: ptend_t (기온 경향)</a:t>
+              <a:t>•   짝이 되는 출력: ptend_t (기온 경향)</a:t>
             </a:r>
             <a:endParaRPr lang="en-US" sz="1550" dirty="0"/>
           </a:p>
           <a:p>
-            <a:pPr marL="342900" indent="-342900">
+            <a:pPr indent="0" marL="0">
               <a:spcAft>
                 <a:spcPts val="900"/>
               </a:spcAft>
-              <a:buSzPct val="100000"/>
-              <a:buChar char="•"/>
+              <a:buNone/>
             </a:pPr>
             <a:r>
               <a:rPr lang="en-US" sz="1550" dirty="0">
@@ -8844,7 +8840,7 @@
                   <a:srgbClr val="13233A"/>
                 </a:solidFill>
               </a:rPr>
-              <a:t>기온은 대기 안정도·복사를 좌우하는 핵심 상태</a:t>
+              <a:t>•   기온은 대기 안정도·복사를 좌우하는 핵심 상태</a:t>
             </a:r>
             <a:endParaRPr lang="en-US" sz="1550" dirty="0"/>
           </a:p>
@@ -9317,12 +9313,11 @@
           <a:bodyPr wrap="square" rtlCol="0" anchor="t"/>
           <a:lstStyle/>
           <a:p>
-            <a:pPr marL="342900" indent="-342900">
+            <a:pPr indent="0" marL="0">
               <a:spcAft>
                 <a:spcPts val="900"/>
               </a:spcAft>
-              <a:buSzPct val="100000"/>
-              <a:buChar char="•"/>
+              <a:buNone/>
             </a:pPr>
             <a:r>
               <a:rPr lang="en-US" sz="1550" dirty="0">
@@ -9330,17 +9325,16 @@
                   <a:srgbClr val="13233A"/>
                 </a:solidFill>
               </a:rPr>
-              <a:t>단위 질량 공기가 머금은 수증기량</a:t>
+              <a:t>•   단위 질량 공기가 머금은 수증기량</a:t>
             </a:r>
             <a:endParaRPr lang="en-US" sz="1550" dirty="0"/>
           </a:p>
           <a:p>
-            <a:pPr marL="342900" indent="-342900">
+            <a:pPr indent="0" marL="0">
               <a:spcAft>
                 <a:spcPts val="900"/>
               </a:spcAft>
-              <a:buSzPct val="100000"/>
-              <a:buChar char="•"/>
+              <a:buNone/>
             </a:pPr>
             <a:r>
               <a:rPr lang="en-US" sz="1550" dirty="0">
@@ -9348,17 +9342,16 @@
                   <a:srgbClr val="13233A"/>
                 </a:solidFill>
               </a:rPr>
-              <a:t>대부분 하층에 집중, 상층은 거의 0</a:t>
+              <a:t>•   대부분 하층에 집중, 상층은 거의 0</a:t>
             </a:r>
             <a:endParaRPr lang="en-US" sz="1550" dirty="0"/>
           </a:p>
           <a:p>
-            <a:pPr marL="342900" indent="-342900">
+            <a:pPr indent="0" marL="0">
               <a:spcAft>
                 <a:spcPts val="900"/>
               </a:spcAft>
-              <a:buSzPct val="100000"/>
-              <a:buChar char="•"/>
+              <a:buNone/>
             </a:pPr>
             <a:r>
               <a:rPr lang="en-US" sz="1550" dirty="0">
@@ -9366,17 +9359,16 @@
                   <a:srgbClr val="13233A"/>
                 </a:solidFill>
               </a:rPr>
-              <a:t>짝이 되는 출력: ptend_q0001 (수증기 경향)</a:t>
+              <a:t>•   짝이 되는 출력: ptend_q0001 (수증기 경향)</a:t>
             </a:r>
             <a:endParaRPr lang="en-US" sz="1550" dirty="0"/>
           </a:p>
           <a:p>
-            <a:pPr marL="342900" indent="-342900">
+            <a:pPr indent="0" marL="0">
               <a:spcAft>
                 <a:spcPts val="900"/>
               </a:spcAft>
-              <a:buSzPct val="100000"/>
-              <a:buChar char="•"/>
+              <a:buNone/>
             </a:pPr>
             <a:r>
               <a:rPr lang="en-US" sz="1550" dirty="0">
@@ -9384,7 +9376,7 @@
                   <a:srgbClr val="13233A"/>
                 </a:solidFill>
               </a:rPr>
-              <a:t>구름·강수의 '연료'가 되는 변수</a:t>
+              <a:t>•   구름·강수의 '연료'가 되는 변수</a:t>
             </a:r>
             <a:endParaRPr lang="en-US" sz="1550" dirty="0"/>
           </a:p>
@@ -13431,12 +13423,11 @@
           <a:bodyPr wrap="square" rtlCol="0" anchor="t"/>
           <a:lstStyle/>
           <a:p>
-            <a:pPr marL="342900" indent="-342900">
+            <a:pPr indent="0" marL="0">
               <a:spcAft>
                 <a:spcPts val="900"/>
               </a:spcAft>
-              <a:buSzPct val="100000"/>
-              <a:buChar char="•"/>
+              <a:buNone/>
             </a:pPr>
             <a:r>
               <a:rPr lang="en-US" sz="1550" dirty="0">
@@ -13444,17 +13435,16 @@
                   <a:srgbClr val="13233A"/>
                 </a:solidFill>
               </a:rPr>
-              <a:t>각 층 기온이 얼마나 빠르게 변하는지</a:t>
+              <a:t>•   각 층 기온이 얼마나 빠르게 변하는지</a:t>
             </a:r>
             <a:endParaRPr lang="en-US" sz="1550" dirty="0"/>
           </a:p>
           <a:p>
-            <a:pPr marL="342900" indent="-342900">
+            <a:pPr indent="0" marL="0">
               <a:spcAft>
                 <a:spcPts val="900"/>
               </a:spcAft>
-              <a:buSzPct val="100000"/>
-              <a:buChar char="•"/>
+              <a:buNone/>
             </a:pPr>
             <a:r>
               <a:rPr lang="en-US" sz="1550" dirty="0">
@@ -13462,17 +13452,16 @@
                   <a:srgbClr val="13233A"/>
                 </a:solidFill>
               </a:rPr>
-              <a:t>복사 가열·냉각과 대류로 결정</a:t>
+              <a:t>•   복사 가열·냉각과 대류로 결정</a:t>
             </a:r>
             <a:endParaRPr lang="en-US" sz="1550" dirty="0"/>
           </a:p>
           <a:p>
-            <a:pPr marL="342900" indent="-342900">
+            <a:pPr indent="0" marL="0">
               <a:spcAft>
                 <a:spcPts val="900"/>
               </a:spcAft>
-              <a:buSzPct val="100000"/>
-              <a:buChar char="•"/>
+              <a:buNone/>
             </a:pPr>
             <a:r>
               <a:rPr lang="en-US" sz="1550" dirty="0">
@@ -13480,17 +13469,16 @@
                   <a:srgbClr val="13233A"/>
                 </a:solidFill>
               </a:rPr>
-              <a:t>예측 난이도: 중간</a:t>
+              <a:t>•   예측 난이도: 중간</a:t>
             </a:r>
             <a:endParaRPr lang="en-US" sz="1550" dirty="0"/>
           </a:p>
           <a:p>
-            <a:pPr marL="342900" indent="-342900">
+            <a:pPr indent="0" marL="0">
               <a:spcAft>
                 <a:spcPts val="900"/>
               </a:spcAft>
-              <a:buSzPct val="100000"/>
-              <a:buChar char="•"/>
+              <a:buNone/>
             </a:pPr>
             <a:r>
               <a:rPr lang="en-US" sz="1550" dirty="0">
@@ -13498,7 +13486,7 @@
                   <a:srgbClr val="13233A"/>
                 </a:solidFill>
               </a:rPr>
-              <a:t>입력 state_t 와 짝을 이룬다</a:t>
+              <a:t>•   입력 state_t 와 짝을 이룬다</a:t>
             </a:r>
             <a:endParaRPr lang="en-US" sz="1550" dirty="0"/>
           </a:p>

</xml_diff>